<commit_message>
Updating numbers, conference photo
</commit_message>
<xml_diff>
--- a/IntroductoryTalkTemplate/Showcasing Orchard Core CMS.pptx
+++ b/IntroductoryTalkTemplate/Showcasing Orchard Core CMS.pptx
@@ -262,7 +262,7 @@
           <a:p>
             <a:fld id="{E4359F16-E075-46EA-9430-278A6D2F0D2B}" type="datetimeFigureOut">
               <a:rPr lang="en-US" smtClean="0"/>
-              <a:t>8/27/2024</a:t>
+              <a:t>2/1/2025</a:t>
             </a:fld>
             <a:endParaRPr lang="en-US"/>
           </a:p>
@@ -1835,7 +1835,7 @@
           <a:p>
             <a:fld id="{20A66C5D-9C61-42DD-99EE-FB9C623F065C}" type="datetimeFigureOut">
               <a:rPr lang="en-US" smtClean="0"/>
-              <a:t>8/27/2024</a:t>
+              <a:t>2/1/2025</a:t>
             </a:fld>
             <a:endParaRPr lang="en-US"/>
           </a:p>
@@ -2033,7 +2033,7 @@
           <a:p>
             <a:fld id="{20A66C5D-9C61-42DD-99EE-FB9C623F065C}" type="datetimeFigureOut">
               <a:rPr lang="en-US" smtClean="0"/>
-              <a:t>8/27/2024</a:t>
+              <a:t>2/1/2025</a:t>
             </a:fld>
             <a:endParaRPr lang="en-US"/>
           </a:p>
@@ -2241,7 +2241,7 @@
           <a:p>
             <a:fld id="{20A66C5D-9C61-42DD-99EE-FB9C623F065C}" type="datetimeFigureOut">
               <a:rPr lang="en-US" smtClean="0"/>
-              <a:t>8/27/2024</a:t>
+              <a:t>2/1/2025</a:t>
             </a:fld>
             <a:endParaRPr lang="en-US"/>
           </a:p>
@@ -2439,7 +2439,7 @@
           <a:p>
             <a:fld id="{20A66C5D-9C61-42DD-99EE-FB9C623F065C}" type="datetimeFigureOut">
               <a:rPr lang="en-US" smtClean="0"/>
-              <a:t>8/27/2024</a:t>
+              <a:t>2/1/2025</a:t>
             </a:fld>
             <a:endParaRPr lang="en-US"/>
           </a:p>
@@ -2714,7 +2714,7 @@
           <a:p>
             <a:fld id="{20A66C5D-9C61-42DD-99EE-FB9C623F065C}" type="datetimeFigureOut">
               <a:rPr lang="en-US" smtClean="0"/>
-              <a:t>8/27/2024</a:t>
+              <a:t>2/1/2025</a:t>
             </a:fld>
             <a:endParaRPr lang="en-US"/>
           </a:p>
@@ -2979,7 +2979,7 @@
           <a:p>
             <a:fld id="{20A66C5D-9C61-42DD-99EE-FB9C623F065C}" type="datetimeFigureOut">
               <a:rPr lang="en-US" smtClean="0"/>
-              <a:t>8/27/2024</a:t>
+              <a:t>2/1/2025</a:t>
             </a:fld>
             <a:endParaRPr lang="en-US"/>
           </a:p>
@@ -3391,7 +3391,7 @@
           <a:p>
             <a:fld id="{20A66C5D-9C61-42DD-99EE-FB9C623F065C}" type="datetimeFigureOut">
               <a:rPr lang="en-US" smtClean="0"/>
-              <a:t>8/27/2024</a:t>
+              <a:t>2/1/2025</a:t>
             </a:fld>
             <a:endParaRPr lang="en-US"/>
           </a:p>
@@ -3532,7 +3532,7 @@
           <a:p>
             <a:fld id="{20A66C5D-9C61-42DD-99EE-FB9C623F065C}" type="datetimeFigureOut">
               <a:rPr lang="en-US" smtClean="0"/>
-              <a:t>8/27/2024</a:t>
+              <a:t>2/1/2025</a:t>
             </a:fld>
             <a:endParaRPr lang="en-US"/>
           </a:p>
@@ -3645,7 +3645,7 @@
           <a:p>
             <a:fld id="{20A66C5D-9C61-42DD-99EE-FB9C623F065C}" type="datetimeFigureOut">
               <a:rPr lang="en-US" smtClean="0"/>
-              <a:t>8/27/2024</a:t>
+              <a:t>2/1/2025</a:t>
             </a:fld>
             <a:endParaRPr lang="en-US"/>
           </a:p>
@@ -3956,7 +3956,7 @@
           <a:p>
             <a:fld id="{20A66C5D-9C61-42DD-99EE-FB9C623F065C}" type="datetimeFigureOut">
               <a:rPr lang="en-US" smtClean="0"/>
-              <a:t>8/27/2024</a:t>
+              <a:t>2/1/2025</a:t>
             </a:fld>
             <a:endParaRPr lang="en-US"/>
           </a:p>
@@ -4244,7 +4244,7 @@
           <a:p>
             <a:fld id="{20A66C5D-9C61-42DD-99EE-FB9C623F065C}" type="datetimeFigureOut">
               <a:rPr lang="en-US" smtClean="0"/>
-              <a:t>8/27/2024</a:t>
+              <a:t>2/1/2025</a:t>
             </a:fld>
             <a:endParaRPr lang="en-US"/>
           </a:p>
@@ -4485,7 +4485,7 @@
           <a:p>
             <a:fld id="{20A66C5D-9C61-42DD-99EE-FB9C623F065C}" type="datetimeFigureOut">
               <a:rPr lang="en-US" smtClean="0"/>
-              <a:t>8/27/2024</a:t>
+              <a:t>2/1/2025</a:t>
             </a:fld>
             <a:endParaRPr lang="en-US"/>
           </a:p>
@@ -5818,7 +5818,7 @@
               <a:rPr lang="en-US" dirty="0">
                 <a:cs typeface="Calibri"/>
               </a:rPr>
-              <a:t>80</a:t>
+              <a:t>85</a:t>
             </a:r>
             <a:r>
               <a:rPr lang="hu-HU" dirty="0">
@@ -5842,7 +5842,7 @@
               <a:rPr lang="en-US" dirty="0">
                 <a:cs typeface="Calibri"/>
               </a:rPr>
-              <a:t>280</a:t>
+              <a:t>300</a:t>
             </a:r>
             <a:r>
               <a:rPr lang="hu-HU" dirty="0">
@@ -5866,7 +5866,7 @@
               <a:rPr lang="en-US" dirty="0">
                 <a:cs typeface="Calibri"/>
               </a:rPr>
-              <a:t>68</a:t>
+              <a:t>70</a:t>
             </a:r>
             <a:r>
               <a:rPr lang="hu-HU" dirty="0">
@@ -5890,7 +5890,7 @@
               <a:rPr lang="en-US" dirty="0">
                 <a:cs typeface="Calibri"/>
               </a:rPr>
-              <a:t>59</a:t>
+              <a:t>61</a:t>
             </a:r>
             <a:r>
               <a:rPr lang="hu-HU" dirty="0">
@@ -6406,10 +6406,10 @@
       </p:sp>
       <p:pic>
         <p:nvPicPr>
-          <p:cNvPr id="4" name="Picture 3" descr="A group of people posing for a photo&#10;&#10;Description automatically generated">
-            <a:extLst>
-              <a:ext uri="{FF2B5EF4-FFF2-40B4-BE49-F238E27FC236}">
-                <a16:creationId xmlns:a16="http://schemas.microsoft.com/office/drawing/2014/main" id="{D47FB301-ECCA-4BC2-91A0-A9E645BF0969}"/>
+          <p:cNvPr id="5" name="Picture 4" descr="A group of people posing for a photo&#10;&#10;Description automatically generated">
+            <a:extLst>
+              <a:ext uri="{FF2B5EF4-FFF2-40B4-BE49-F238E27FC236}">
+                <a16:creationId xmlns:a16="http://schemas.microsoft.com/office/drawing/2014/main" id="{607EBF1C-23AE-050C-3281-2E09B8AAD5C7}"/>
               </a:ext>
             </a:extLst>
           </p:cNvPr>
@@ -6419,7 +6419,7 @@
           <p:nvPr/>
         </p:nvPicPr>
         <p:blipFill>
-          <a:blip r:embed="rId3" cstate="print">
+          <a:blip r:embed="rId3">
             <a:extLst>
               <a:ext uri="{28A0092B-C50C-407E-A947-70E740481C1C}">
                 <a14:useLocalDpi xmlns:a14="http://schemas.microsoft.com/office/drawing/2010/main" val="0"/>
@@ -6432,8 +6432,8 @@
         </p:blipFill>
         <p:spPr>
           <a:xfrm>
-            <a:off x="2531887" y="1329563"/>
-            <a:ext cx="7128225" cy="5346169"/>
+            <a:off x="838200" y="1320546"/>
+            <a:ext cx="10517207" cy="5434584"/>
           </a:xfrm>
           <a:prstGeom prst="rect">
             <a:avLst/>

</xml_diff>

<commit_message>
Adding notes on OC v2 and 3
</commit_message>
<xml_diff>
--- a/IntroductoryTalkTemplate/Showcasing Orchard Core CMS.pptx
+++ b/IntroductoryTalkTemplate/Showcasing Orchard Core CMS.pptx
@@ -262,7 +262,7 @@
           <a:p>
             <a:fld id="{E4359F16-E075-46EA-9430-278A6D2F0D2B}" type="datetimeFigureOut">
               <a:rPr lang="en-US" smtClean="0"/>
-              <a:t>12/2/2025</a:t>
+              <a:t>1/21/2026</a:t>
             </a:fld>
             <a:endParaRPr lang="en-US"/>
           </a:p>
@@ -1835,7 +1835,7 @@
           <a:p>
             <a:fld id="{20A66C5D-9C61-42DD-99EE-FB9C623F065C}" type="datetimeFigureOut">
               <a:rPr lang="en-US" smtClean="0"/>
-              <a:t>12/2/2025</a:t>
+              <a:t>1/21/2026</a:t>
             </a:fld>
             <a:endParaRPr lang="en-US"/>
           </a:p>
@@ -2033,7 +2033,7 @@
           <a:p>
             <a:fld id="{20A66C5D-9C61-42DD-99EE-FB9C623F065C}" type="datetimeFigureOut">
               <a:rPr lang="en-US" smtClean="0"/>
-              <a:t>12/2/2025</a:t>
+              <a:t>1/21/2026</a:t>
             </a:fld>
             <a:endParaRPr lang="en-US"/>
           </a:p>
@@ -2241,7 +2241,7 @@
           <a:p>
             <a:fld id="{20A66C5D-9C61-42DD-99EE-FB9C623F065C}" type="datetimeFigureOut">
               <a:rPr lang="en-US" smtClean="0"/>
-              <a:t>12/2/2025</a:t>
+              <a:t>1/21/2026</a:t>
             </a:fld>
             <a:endParaRPr lang="en-US"/>
           </a:p>
@@ -2439,7 +2439,7 @@
           <a:p>
             <a:fld id="{20A66C5D-9C61-42DD-99EE-FB9C623F065C}" type="datetimeFigureOut">
               <a:rPr lang="en-US" smtClean="0"/>
-              <a:t>12/2/2025</a:t>
+              <a:t>1/21/2026</a:t>
             </a:fld>
             <a:endParaRPr lang="en-US"/>
           </a:p>
@@ -2714,7 +2714,7 @@
           <a:p>
             <a:fld id="{20A66C5D-9C61-42DD-99EE-FB9C623F065C}" type="datetimeFigureOut">
               <a:rPr lang="en-US" smtClean="0"/>
-              <a:t>12/2/2025</a:t>
+              <a:t>1/21/2026</a:t>
             </a:fld>
             <a:endParaRPr lang="en-US"/>
           </a:p>
@@ -2979,7 +2979,7 @@
           <a:p>
             <a:fld id="{20A66C5D-9C61-42DD-99EE-FB9C623F065C}" type="datetimeFigureOut">
               <a:rPr lang="en-US" smtClean="0"/>
-              <a:t>12/2/2025</a:t>
+              <a:t>1/21/2026</a:t>
             </a:fld>
             <a:endParaRPr lang="en-US"/>
           </a:p>
@@ -3391,7 +3391,7 @@
           <a:p>
             <a:fld id="{20A66C5D-9C61-42DD-99EE-FB9C623F065C}" type="datetimeFigureOut">
               <a:rPr lang="en-US" smtClean="0"/>
-              <a:t>12/2/2025</a:t>
+              <a:t>1/21/2026</a:t>
             </a:fld>
             <a:endParaRPr lang="en-US"/>
           </a:p>
@@ -3532,7 +3532,7 @@
           <a:p>
             <a:fld id="{20A66C5D-9C61-42DD-99EE-FB9C623F065C}" type="datetimeFigureOut">
               <a:rPr lang="en-US" smtClean="0"/>
-              <a:t>12/2/2025</a:t>
+              <a:t>1/21/2026</a:t>
             </a:fld>
             <a:endParaRPr lang="en-US"/>
           </a:p>
@@ -3645,7 +3645,7 @@
           <a:p>
             <a:fld id="{20A66C5D-9C61-42DD-99EE-FB9C623F065C}" type="datetimeFigureOut">
               <a:rPr lang="en-US" smtClean="0"/>
-              <a:t>12/2/2025</a:t>
+              <a:t>1/21/2026</a:t>
             </a:fld>
             <a:endParaRPr lang="en-US"/>
           </a:p>
@@ -3956,7 +3956,7 @@
           <a:p>
             <a:fld id="{20A66C5D-9C61-42DD-99EE-FB9C623F065C}" type="datetimeFigureOut">
               <a:rPr lang="en-US" smtClean="0"/>
-              <a:t>12/2/2025</a:t>
+              <a:t>1/21/2026</a:t>
             </a:fld>
             <a:endParaRPr lang="en-US"/>
           </a:p>
@@ -4244,7 +4244,7 @@
           <a:p>
             <a:fld id="{20A66C5D-9C61-42DD-99EE-FB9C623F065C}" type="datetimeFigureOut">
               <a:rPr lang="en-US" smtClean="0"/>
-              <a:t>12/2/2025</a:t>
+              <a:t>1/21/2026</a:t>
             </a:fld>
             <a:endParaRPr lang="en-US"/>
           </a:p>
@@ -4485,7 +4485,7 @@
           <a:p>
             <a:fld id="{20A66C5D-9C61-42DD-99EE-FB9C623F065C}" type="datetimeFigureOut">
               <a:rPr lang="en-US" smtClean="0"/>
-              <a:t>12/2/2025</a:t>
+              <a:t>1/21/2026</a:t>
             </a:fld>
             <a:endParaRPr lang="en-US"/>
           </a:p>
@@ -6153,6 +6153,18 @@
             <a:r>
               <a:rPr lang="en-US" dirty="0"/>
               <a:t>1: Orchard Core v1.0</a:t>
+            </a:r>
+          </a:p>
+          <a:p>
+            <a:r>
+              <a:rPr lang="en-US" dirty="0"/>
+              <a:t>2024: Orchard Core v2</a:t>
+            </a:r>
+          </a:p>
+          <a:p>
+            <a:r>
+              <a:rPr lang="en-US" dirty="0"/>
+              <a:t>2026: Orchard Core v3</a:t>
             </a:r>
           </a:p>
         </p:txBody>

</xml_diff>

<commit_message>
Updating numbers, sample sites
</commit_message>
<xml_diff>
--- a/IntroductoryTalkTemplate/Showcasing Orchard Core CMS.pptx
+++ b/IntroductoryTalkTemplate/Showcasing Orchard Core CMS.pptx
@@ -262,7 +262,7 @@
           <a:p>
             <a:fld id="{E4359F16-E075-46EA-9430-278A6D2F0D2B}" type="datetimeFigureOut">
               <a:rPr lang="en-US" smtClean="0"/>
-              <a:t>1/21/2026</a:t>
+              <a:t>7/30/2026</a:t>
             </a:fld>
             <a:endParaRPr lang="en-US"/>
           </a:p>
@@ -1646,8 +1646,12 @@
           <a:lstStyle/>
           <a:p>
             <a:r>
+              <a:rPr lang="en-US" noProof="0"/>
+              <a:t>Have </a:t>
+            </a:r>
+            <a:r>
               <a:rPr lang="en-US" noProof="0" dirty="0"/>
-              <a:t>These are Orchard 1 and Core sites too, so make this clear. Have these open before the presentation so you just need to show them in the browser (you can bookmark them to a bookmark folder so you can easily open them at once).</a:t>
+              <a:t>these open before the presentation so you just need to show them in the browser (you can bookmark them to a bookmark folder so you can easily open them at once).</a:t>
             </a:r>
           </a:p>
         </p:txBody>
@@ -1835,7 +1839,7 @@
           <a:p>
             <a:fld id="{20A66C5D-9C61-42DD-99EE-FB9C623F065C}" type="datetimeFigureOut">
               <a:rPr lang="en-US" smtClean="0"/>
-              <a:t>1/21/2026</a:t>
+              <a:t>7/30/2026</a:t>
             </a:fld>
             <a:endParaRPr lang="en-US"/>
           </a:p>
@@ -2033,7 +2037,7 @@
           <a:p>
             <a:fld id="{20A66C5D-9C61-42DD-99EE-FB9C623F065C}" type="datetimeFigureOut">
               <a:rPr lang="en-US" smtClean="0"/>
-              <a:t>1/21/2026</a:t>
+              <a:t>7/30/2026</a:t>
             </a:fld>
             <a:endParaRPr lang="en-US"/>
           </a:p>
@@ -2241,7 +2245,7 @@
           <a:p>
             <a:fld id="{20A66C5D-9C61-42DD-99EE-FB9C623F065C}" type="datetimeFigureOut">
               <a:rPr lang="en-US" smtClean="0"/>
-              <a:t>1/21/2026</a:t>
+              <a:t>7/30/2026</a:t>
             </a:fld>
             <a:endParaRPr lang="en-US"/>
           </a:p>
@@ -2439,7 +2443,7 @@
           <a:p>
             <a:fld id="{20A66C5D-9C61-42DD-99EE-FB9C623F065C}" type="datetimeFigureOut">
               <a:rPr lang="en-US" smtClean="0"/>
-              <a:t>1/21/2026</a:t>
+              <a:t>7/30/2026</a:t>
             </a:fld>
             <a:endParaRPr lang="en-US"/>
           </a:p>
@@ -2714,7 +2718,7 @@
           <a:p>
             <a:fld id="{20A66C5D-9C61-42DD-99EE-FB9C623F065C}" type="datetimeFigureOut">
               <a:rPr lang="en-US" smtClean="0"/>
-              <a:t>1/21/2026</a:t>
+              <a:t>7/30/2026</a:t>
             </a:fld>
             <a:endParaRPr lang="en-US"/>
           </a:p>
@@ -2979,7 +2983,7 @@
           <a:p>
             <a:fld id="{20A66C5D-9C61-42DD-99EE-FB9C623F065C}" type="datetimeFigureOut">
               <a:rPr lang="en-US" smtClean="0"/>
-              <a:t>1/21/2026</a:t>
+              <a:t>7/30/2026</a:t>
             </a:fld>
             <a:endParaRPr lang="en-US"/>
           </a:p>
@@ -3391,7 +3395,7 @@
           <a:p>
             <a:fld id="{20A66C5D-9C61-42DD-99EE-FB9C623F065C}" type="datetimeFigureOut">
               <a:rPr lang="en-US" smtClean="0"/>
-              <a:t>1/21/2026</a:t>
+              <a:t>7/30/2026</a:t>
             </a:fld>
             <a:endParaRPr lang="en-US"/>
           </a:p>
@@ -3532,7 +3536,7 @@
           <a:p>
             <a:fld id="{20A66C5D-9C61-42DD-99EE-FB9C623F065C}" type="datetimeFigureOut">
               <a:rPr lang="en-US" smtClean="0"/>
-              <a:t>1/21/2026</a:t>
+              <a:t>7/30/2026</a:t>
             </a:fld>
             <a:endParaRPr lang="en-US"/>
           </a:p>
@@ -3645,7 +3649,7 @@
           <a:p>
             <a:fld id="{20A66C5D-9C61-42DD-99EE-FB9C623F065C}" type="datetimeFigureOut">
               <a:rPr lang="en-US" smtClean="0"/>
-              <a:t>1/21/2026</a:t>
+              <a:t>7/30/2026</a:t>
             </a:fld>
             <a:endParaRPr lang="en-US"/>
           </a:p>
@@ -3956,7 +3960,7 @@
           <a:p>
             <a:fld id="{20A66C5D-9C61-42DD-99EE-FB9C623F065C}" type="datetimeFigureOut">
               <a:rPr lang="en-US" smtClean="0"/>
-              <a:t>1/21/2026</a:t>
+              <a:t>7/30/2026</a:t>
             </a:fld>
             <a:endParaRPr lang="en-US"/>
           </a:p>
@@ -4244,7 +4248,7 @@
           <a:p>
             <a:fld id="{20A66C5D-9C61-42DD-99EE-FB9C623F065C}" type="datetimeFigureOut">
               <a:rPr lang="en-US" smtClean="0"/>
-              <a:t>1/21/2026</a:t>
+              <a:t>7/30/2026</a:t>
             </a:fld>
             <a:endParaRPr lang="en-US"/>
           </a:p>
@@ -4485,7 +4489,7 @@
           <a:p>
             <a:fld id="{20A66C5D-9C61-42DD-99EE-FB9C623F065C}" type="datetimeFigureOut">
               <a:rPr lang="en-US" smtClean="0"/>
-              <a:t>1/21/2026</a:t>
+              <a:t>7/30/2026</a:t>
             </a:fld>
             <a:endParaRPr lang="en-US"/>
           </a:p>
@@ -5043,7 +5047,7 @@
         <p:spPr/>
         <p:txBody>
           <a:bodyPr>
-            <a:normAutofit fontScale="92500" lnSpcReduction="20000"/>
+            <a:normAutofit lnSpcReduction="10000"/>
           </a:bodyPr>
           <a:lstStyle/>
           <a:p>
@@ -5051,7 +5055,7 @@
               <a:rPr lang="en-US" dirty="0">
                 <a:hlinkClick r:id="rId3"/>
               </a:rPr>
-              <a:t>https://www.playtfr.com/</a:t>
+              <a:t>https://www.rvc.ac.uk/</a:t>
             </a:r>
             <a:endParaRPr lang="en-US" dirty="0"/>
           </a:p>
@@ -5060,7 +5064,7 @@
               <a:rPr lang="en-US" dirty="0">
                 <a:hlinkClick r:id="rId4"/>
               </a:rPr>
-              <a:t>https://www.rvc.ac.uk/</a:t>
+              <a:t>https://mypension.sony.co.uk/</a:t>
             </a:r>
             <a:endParaRPr lang="en-US" dirty="0"/>
           </a:p>
@@ -5069,18 +5073,24 @@
               <a:rPr lang="en-US" dirty="0">
                 <a:hlinkClick r:id="rId5"/>
               </a:rPr>
-              <a:t>https://www.houseofblues.com/</a:t>
-            </a:r>
-            <a:endParaRPr lang="en-US" dirty="0"/>
+              <a:t>https://customer-services-parts.cz.daimlertruck.com/</a:t>
+            </a:r>
+            <a:r>
+              <a:rPr lang="en-US" dirty="0"/>
+              <a:t> </a:t>
+            </a:r>
           </a:p>
           <a:p>
             <a:r>
               <a:rPr lang="en-US" dirty="0">
                 <a:hlinkClick r:id="rId6"/>
               </a:rPr>
-              <a:t>https://mypension.sony.co.uk/</a:t>
-            </a:r>
-            <a:endParaRPr lang="en-US" dirty="0"/>
+              <a:t>https://usafa.org/</a:t>
+            </a:r>
+            <a:r>
+              <a:rPr lang="en-US" dirty="0"/>
+              <a:t> </a:t>
+            </a:r>
           </a:p>
           <a:p>
             <a:r>
@@ -5096,7 +5106,7 @@
               <a:rPr lang="en-US" dirty="0">
                 <a:hlinkClick r:id="rId8"/>
               </a:rPr>
-              <a:t>https://capri.co.za/</a:t>
+              <a:t>https://roswell.ilea.state.gov/</a:t>
             </a:r>
             <a:endParaRPr lang="en-US" dirty="0"/>
           </a:p>
@@ -5105,7 +5115,7 @@
               <a:rPr lang="en-US" dirty="0">
                 <a:hlinkClick r:id="rId9"/>
               </a:rPr>
-              <a:t>https://roswell.ilea.state.gov/</a:t>
+              <a:t>https://folkways.si.edu/</a:t>
             </a:r>
             <a:endParaRPr lang="en-US" dirty="0"/>
           </a:p>
@@ -5114,27 +5124,18 @@
               <a:rPr lang="en-US" dirty="0">
                 <a:hlinkClick r:id="rId10"/>
               </a:rPr>
-              <a:t>https://folkways.si.edu/</a:t>
+              <a:t>https://santamonica.gov/</a:t>
             </a:r>
             <a:endParaRPr lang="en-US" dirty="0"/>
           </a:p>
           <a:p>
+            <a:r>
+              <a:rPr lang="en-US" dirty="0"/>
+              <a:t>Also see </a:t>
+            </a:r>
             <a:r>
               <a:rPr lang="en-US" dirty="0">
                 <a:hlinkClick r:id="rId11"/>
-              </a:rPr>
-              <a:t>https://santamonica.gov/</a:t>
-            </a:r>
-            <a:endParaRPr lang="en-US" dirty="0"/>
-          </a:p>
-          <a:p>
-            <a:r>
-              <a:rPr lang="en-US"/>
-              <a:t>Also see </a:t>
-            </a:r>
-            <a:r>
-              <a:rPr lang="en-US">
-                <a:hlinkClick r:id="rId12"/>
               </a:rPr>
               <a:t>https://showorchard.com/</a:t>
             </a:r>
@@ -5833,7 +5834,7 @@
               <a:rPr lang="en-US" dirty="0">
                 <a:cs typeface="Calibri"/>
               </a:rPr>
-              <a:t>90</a:t>
+              <a:t>80</a:t>
             </a:r>
             <a:r>
               <a:rPr lang="hu-HU" dirty="0">
@@ -5857,7 +5858,7 @@
               <a:rPr lang="en-US" dirty="0">
                 <a:cs typeface="Calibri"/>
               </a:rPr>
-              <a:t>320</a:t>
+              <a:t>340</a:t>
             </a:r>
             <a:r>
               <a:rPr lang="hu-HU" dirty="0">
@@ -5881,7 +5882,7 @@
               <a:rPr lang="en-US" dirty="0">
                 <a:cs typeface="Calibri"/>
               </a:rPr>
-              <a:t>73</a:t>
+              <a:t>74</a:t>
             </a:r>
             <a:r>
               <a:rPr lang="hu-HU" dirty="0">
@@ -5905,7 +5906,7 @@
               <a:rPr lang="en-US" dirty="0">
                 <a:cs typeface="Calibri"/>
               </a:rPr>
-              <a:t>64</a:t>
+              <a:t>66</a:t>
             </a:r>
             <a:r>
               <a:rPr lang="hu-HU" dirty="0">

</xml_diff>

<commit_message>
Updating numbers, O1 slide
</commit_message>
<xml_diff>
--- a/IntroductoryTalkTemplate/Showcasing Orchard Core CMS.pptx
+++ b/IntroductoryTalkTemplate/Showcasing Orchard Core CMS.pptx
@@ -262,7 +262,7 @@
           <a:p>
             <a:fld id="{E4359F16-E075-46EA-9430-278A6D2F0D2B}" type="datetimeFigureOut">
               <a:rPr lang="en-US" smtClean="0"/>
-              <a:t>7/30/2026</a:t>
+              <a:t>8/16/2026</a:t>
             </a:fld>
             <a:endParaRPr lang="en-US"/>
           </a:p>
@@ -1839,7 +1839,7 @@
           <a:p>
             <a:fld id="{20A66C5D-9C61-42DD-99EE-FB9C623F065C}" type="datetimeFigureOut">
               <a:rPr lang="en-US" smtClean="0"/>
-              <a:t>7/30/2026</a:t>
+              <a:t>8/16/2026</a:t>
             </a:fld>
             <a:endParaRPr lang="en-US"/>
           </a:p>
@@ -2037,7 +2037,7 @@
           <a:p>
             <a:fld id="{20A66C5D-9C61-42DD-99EE-FB9C623F065C}" type="datetimeFigureOut">
               <a:rPr lang="en-US" smtClean="0"/>
-              <a:t>7/30/2026</a:t>
+              <a:t>8/16/2026</a:t>
             </a:fld>
             <a:endParaRPr lang="en-US"/>
           </a:p>
@@ -2245,7 +2245,7 @@
           <a:p>
             <a:fld id="{20A66C5D-9C61-42DD-99EE-FB9C623F065C}" type="datetimeFigureOut">
               <a:rPr lang="en-US" smtClean="0"/>
-              <a:t>7/30/2026</a:t>
+              <a:t>8/16/2026</a:t>
             </a:fld>
             <a:endParaRPr lang="en-US"/>
           </a:p>
@@ -2443,7 +2443,7 @@
           <a:p>
             <a:fld id="{20A66C5D-9C61-42DD-99EE-FB9C623F065C}" type="datetimeFigureOut">
               <a:rPr lang="en-US" smtClean="0"/>
-              <a:t>7/30/2026</a:t>
+              <a:t>8/16/2026</a:t>
             </a:fld>
             <a:endParaRPr lang="en-US"/>
           </a:p>
@@ -2718,7 +2718,7 @@
           <a:p>
             <a:fld id="{20A66C5D-9C61-42DD-99EE-FB9C623F065C}" type="datetimeFigureOut">
               <a:rPr lang="en-US" smtClean="0"/>
-              <a:t>7/30/2026</a:t>
+              <a:t>8/16/2026</a:t>
             </a:fld>
             <a:endParaRPr lang="en-US"/>
           </a:p>
@@ -2983,7 +2983,7 @@
           <a:p>
             <a:fld id="{20A66C5D-9C61-42DD-99EE-FB9C623F065C}" type="datetimeFigureOut">
               <a:rPr lang="en-US" smtClean="0"/>
-              <a:t>7/30/2026</a:t>
+              <a:t>8/16/2026</a:t>
             </a:fld>
             <a:endParaRPr lang="en-US"/>
           </a:p>
@@ -3395,7 +3395,7 @@
           <a:p>
             <a:fld id="{20A66C5D-9C61-42DD-99EE-FB9C623F065C}" type="datetimeFigureOut">
               <a:rPr lang="en-US" smtClean="0"/>
-              <a:t>7/30/2026</a:t>
+              <a:t>8/16/2026</a:t>
             </a:fld>
             <a:endParaRPr lang="en-US"/>
           </a:p>
@@ -3536,7 +3536,7 @@
           <a:p>
             <a:fld id="{20A66C5D-9C61-42DD-99EE-FB9C623F065C}" type="datetimeFigureOut">
               <a:rPr lang="en-US" smtClean="0"/>
-              <a:t>7/30/2026</a:t>
+              <a:t>8/16/2026</a:t>
             </a:fld>
             <a:endParaRPr lang="en-US"/>
           </a:p>
@@ -3649,7 +3649,7 @@
           <a:p>
             <a:fld id="{20A66C5D-9C61-42DD-99EE-FB9C623F065C}" type="datetimeFigureOut">
               <a:rPr lang="en-US" smtClean="0"/>
-              <a:t>7/30/2026</a:t>
+              <a:t>8/16/2026</a:t>
             </a:fld>
             <a:endParaRPr lang="en-US"/>
           </a:p>
@@ -3960,7 +3960,7 @@
           <a:p>
             <a:fld id="{20A66C5D-9C61-42DD-99EE-FB9C623F065C}" type="datetimeFigureOut">
               <a:rPr lang="en-US" smtClean="0"/>
-              <a:t>7/30/2026</a:t>
+              <a:t>8/16/2026</a:t>
             </a:fld>
             <a:endParaRPr lang="en-US"/>
           </a:p>
@@ -4248,7 +4248,7 @@
           <a:p>
             <a:fld id="{20A66C5D-9C61-42DD-99EE-FB9C623F065C}" type="datetimeFigureOut">
               <a:rPr lang="en-US" smtClean="0"/>
-              <a:t>7/30/2026</a:t>
+              <a:t>8/16/2026</a:t>
             </a:fld>
             <a:endParaRPr lang="en-US"/>
           </a:p>
@@ -4489,7 +4489,7 @@
           <a:p>
             <a:fld id="{20A66C5D-9C61-42DD-99EE-FB9C623F065C}" type="datetimeFigureOut">
               <a:rPr lang="en-US" smtClean="0"/>
-              <a:t>7/30/2026</a:t>
+              <a:t>8/16/2026</a:t>
             </a:fld>
             <a:endParaRPr lang="en-US"/>
           </a:p>
@@ -5834,7 +5834,7 @@
               <a:rPr lang="en-US" dirty="0">
                 <a:cs typeface="Calibri"/>
               </a:rPr>
-              <a:t>80</a:t>
+              <a:t>98</a:t>
             </a:r>
             <a:r>
               <a:rPr lang="hu-HU" dirty="0">
@@ -5925,6 +5925,18 @@
                 <a:cs typeface="Calibri"/>
               </a:rPr>
               <a:t>)</a:t>
+            </a:r>
+            <a:endParaRPr lang="en-US" dirty="0">
+              <a:cs typeface="Calibri"/>
+            </a:endParaRPr>
+          </a:p>
+          <a:p>
+            <a:r>
+              <a:rPr lang="en-US" dirty="0">
+                <a:ea typeface="+mn-lt"/>
+                <a:cs typeface="Calibri"/>
+              </a:rPr>
+              <a:t>Among the most active .NET Foundation projects</a:t>
             </a:r>
             <a:endParaRPr lang="hu-HU" dirty="0">
               <a:ea typeface="+mn-lt"/>
@@ -6016,21 +6028,13 @@
           <a:p>
             <a:r>
               <a:rPr lang="en-US" dirty="0"/>
+              <a:t>The original Orchard CMS started in 2009</a:t>
+            </a:r>
+          </a:p>
+          <a:p>
+            <a:r>
+              <a:rPr lang="en-US" dirty="0"/>
               <a:t>.NET Framework, ASP.NET MVC</a:t>
-            </a:r>
-          </a:p>
-          <a:p>
-            <a:r>
-              <a:rPr lang="en-US" dirty="0"/>
-              <a:t>11900 commits, 19</a:t>
-            </a:r>
-            <a:r>
-              <a:rPr lang="hu-HU" dirty="0"/>
-              <a:t>0</a:t>
-            </a:r>
-            <a:r>
-              <a:rPr lang="en-US" dirty="0"/>
-              <a:t> contributors, 7400 issues (5600 closed)</a:t>
             </a:r>
           </a:p>
           <a:p>
@@ -6153,7 +6157,7 @@
             </a:r>
             <a:r>
               <a:rPr lang="en-US" dirty="0"/>
-              <a:t>1: Orchard Core v1.0</a:t>
+              <a:t>1: Orchard Core v1</a:t>
             </a:r>
           </a:p>
           <a:p>

</xml_diff>

<commit_message>
Some more points on why OC
</commit_message>
<xml_diff>
--- a/IntroductoryTalkTemplate/Showcasing Orchard Core CMS.pptx
+++ b/IntroductoryTalkTemplate/Showcasing Orchard Core CMS.pptx
@@ -262,7 +262,7 @@
           <a:p>
             <a:fld id="{E4359F16-E075-46EA-9430-278A6D2F0D2B}" type="datetimeFigureOut">
               <a:rPr lang="en-US" smtClean="0"/>
-              <a:t>8/16/2026</a:t>
+              <a:t>8/18/2026</a:t>
             </a:fld>
             <a:endParaRPr lang="en-US"/>
           </a:p>
@@ -1839,7 +1839,7 @@
           <a:p>
             <a:fld id="{20A66C5D-9C61-42DD-99EE-FB9C623F065C}" type="datetimeFigureOut">
               <a:rPr lang="en-US" smtClean="0"/>
-              <a:t>8/16/2026</a:t>
+              <a:t>8/18/2026</a:t>
             </a:fld>
             <a:endParaRPr lang="en-US"/>
           </a:p>
@@ -2037,7 +2037,7 @@
           <a:p>
             <a:fld id="{20A66C5D-9C61-42DD-99EE-FB9C623F065C}" type="datetimeFigureOut">
               <a:rPr lang="en-US" smtClean="0"/>
-              <a:t>8/16/2026</a:t>
+              <a:t>8/18/2026</a:t>
             </a:fld>
             <a:endParaRPr lang="en-US"/>
           </a:p>
@@ -2245,7 +2245,7 @@
           <a:p>
             <a:fld id="{20A66C5D-9C61-42DD-99EE-FB9C623F065C}" type="datetimeFigureOut">
               <a:rPr lang="en-US" smtClean="0"/>
-              <a:t>8/16/2026</a:t>
+              <a:t>8/18/2026</a:t>
             </a:fld>
             <a:endParaRPr lang="en-US"/>
           </a:p>
@@ -2443,7 +2443,7 @@
           <a:p>
             <a:fld id="{20A66C5D-9C61-42DD-99EE-FB9C623F065C}" type="datetimeFigureOut">
               <a:rPr lang="en-US" smtClean="0"/>
-              <a:t>8/16/2026</a:t>
+              <a:t>8/18/2026</a:t>
             </a:fld>
             <a:endParaRPr lang="en-US"/>
           </a:p>
@@ -2718,7 +2718,7 @@
           <a:p>
             <a:fld id="{20A66C5D-9C61-42DD-99EE-FB9C623F065C}" type="datetimeFigureOut">
               <a:rPr lang="en-US" smtClean="0"/>
-              <a:t>8/16/2026</a:t>
+              <a:t>8/18/2026</a:t>
             </a:fld>
             <a:endParaRPr lang="en-US"/>
           </a:p>
@@ -2983,7 +2983,7 @@
           <a:p>
             <a:fld id="{20A66C5D-9C61-42DD-99EE-FB9C623F065C}" type="datetimeFigureOut">
               <a:rPr lang="en-US" smtClean="0"/>
-              <a:t>8/16/2026</a:t>
+              <a:t>8/18/2026</a:t>
             </a:fld>
             <a:endParaRPr lang="en-US"/>
           </a:p>
@@ -3395,7 +3395,7 @@
           <a:p>
             <a:fld id="{20A66C5D-9C61-42DD-99EE-FB9C623F065C}" type="datetimeFigureOut">
               <a:rPr lang="en-US" smtClean="0"/>
-              <a:t>8/16/2026</a:t>
+              <a:t>8/18/2026</a:t>
             </a:fld>
             <a:endParaRPr lang="en-US"/>
           </a:p>
@@ -3536,7 +3536,7 @@
           <a:p>
             <a:fld id="{20A66C5D-9C61-42DD-99EE-FB9C623F065C}" type="datetimeFigureOut">
               <a:rPr lang="en-US" smtClean="0"/>
-              <a:t>8/16/2026</a:t>
+              <a:t>8/18/2026</a:t>
             </a:fld>
             <a:endParaRPr lang="en-US"/>
           </a:p>
@@ -3649,7 +3649,7 @@
           <a:p>
             <a:fld id="{20A66C5D-9C61-42DD-99EE-FB9C623F065C}" type="datetimeFigureOut">
               <a:rPr lang="en-US" smtClean="0"/>
-              <a:t>8/16/2026</a:t>
+              <a:t>8/18/2026</a:t>
             </a:fld>
             <a:endParaRPr lang="en-US"/>
           </a:p>
@@ -3960,7 +3960,7 @@
           <a:p>
             <a:fld id="{20A66C5D-9C61-42DD-99EE-FB9C623F065C}" type="datetimeFigureOut">
               <a:rPr lang="en-US" smtClean="0"/>
-              <a:t>8/16/2026</a:t>
+              <a:t>8/18/2026</a:t>
             </a:fld>
             <a:endParaRPr lang="en-US"/>
           </a:p>
@@ -4248,7 +4248,7 @@
           <a:p>
             <a:fld id="{20A66C5D-9C61-42DD-99EE-FB9C623F065C}" type="datetimeFigureOut">
               <a:rPr lang="en-US" smtClean="0"/>
-              <a:t>8/16/2026</a:t>
+              <a:t>8/18/2026</a:t>
             </a:fld>
             <a:endParaRPr lang="en-US"/>
           </a:p>
@@ -4489,7 +4489,7 @@
           <a:p>
             <a:fld id="{20A66C5D-9C61-42DD-99EE-FB9C623F065C}" type="datetimeFigureOut">
               <a:rPr lang="en-US" smtClean="0"/>
-              <a:t>8/16/2026</a:t>
+              <a:t>8/18/2026</a:t>
             </a:fld>
             <a:endParaRPr lang="en-US"/>
           </a:p>
@@ -6367,7 +6367,13 @@
           <a:p>
             <a:r>
               <a:rPr lang="en-US" dirty="0"/>
-              <a:t>Flexible/extensible content/user/media management, multi-tenancy…</a:t>
+              <a:t>Flexible/extensible content/user/media management, multi-tenancy, workflows, audit trail…</a:t>
+            </a:r>
+          </a:p>
+          <a:p>
+            <a:r>
+              <a:rPr lang="en-US" dirty="0"/>
+              <a:t>Community-driven</a:t>
             </a:r>
           </a:p>
           <a:p>

</xml_diff>